<commit_message>
eval: 3x each format with images/tables/charts inside (pdf/docx/pptx/xlsx/csv/txt/md/png)
</commit_message>
<xml_diff>
--- a/eval/dataset/files/lesson.pptx
+++ b/eval/dataset/files/lesson.pptx
@@ -13,6 +13,7 @@
     <p:sldId id="261" r:id="rId12"/>
     <p:sldId id="262" r:id="rId13"/>
     <p:sldId id="263" r:id="rId14"/>
+    <p:sldId id="264" r:id="rId15"/>
   </p:sldIdLst>
   <p:sldSz cx="9144000" cy="6858000" type="screen4x3"/>
   <p:notesSz cx="6858000" cy="9144000"/>
@@ -112,6 +113,135 @@
     </a:lvl9pPr>
   </p:defaultTextStyle>
 </p:presentation>
+</file>
+
+<file path=ppt/charts/chart1.xml><?xml version="1.0" encoding="utf-8"?>
+<c:chartSpace xmlns:c="http://schemas.openxmlformats.org/drawingml/2006/chart" xmlns:a="http://schemas.openxmlformats.org/drawingml/2006/main" xmlns:r="http://schemas.openxmlformats.org/officeDocument/2006/relationships">
+  <c:date1904 val="0"/>
+  <c:chart>
+    <c:autoTitleDeleted val="0"/>
+    <c:plotArea>
+      <c:lineChart>
+        <c:grouping val="standard"/>
+        <c:varyColors val="0"/>
+        <c:ser>
+          <c:idx val="0"/>
+          <c:order val="0"/>
+          <c:tx>
+            <c:strRef>
+              <c:f>Sheet1!$B$1</c:f>
+              <c:strCache>
+                <c:ptCount val="1"/>
+                <c:pt idx="0">
+                  <c:v>current_mA</c:v>
+                </c:pt>
+              </c:strCache>
+            </c:strRef>
+          </c:tx>
+          <c:marker>
+            <c:symbol val="none"/>
+          </c:marker>
+          <c:cat>
+            <c:strRef>
+              <c:f>Sheet1!$A$2:$A$5</c:f>
+              <c:strCache>
+                <c:ptCount val="4"/>
+                <c:pt idx="0">
+                  <c:v>3V</c:v>
+                </c:pt>
+                <c:pt idx="1">
+                  <c:v>6V</c:v>
+                </c:pt>
+                <c:pt idx="2">
+                  <c:v>9V</c:v>
+                </c:pt>
+                <c:pt idx="3">
+                  <c:v>12V</c:v>
+                </c:pt>
+              </c:strCache>
+            </c:strRef>
+          </c:cat>
+          <c:val>
+            <c:numRef>
+              <c:f>Sheet1!$B$2:$B$5</c:f>
+              <c:numCache>
+                <c:formatCode>General</c:formatCode>
+                <c:ptCount val="4"/>
+                <c:pt idx="0">
+                  <c:v>12.0</c:v>
+                </c:pt>
+                <c:pt idx="1">
+                  <c:v>24.0</c:v>
+                </c:pt>
+                <c:pt idx="2">
+                  <c:v>36.0</c:v>
+                </c:pt>
+                <c:pt idx="3">
+                  <c:v>48.0</c:v>
+                </c:pt>
+              </c:numCache>
+            </c:numRef>
+          </c:val>
+          <c:smooth val="0"/>
+        </c:ser>
+        <c:marker val="1"/>
+        <c:smooth val="0"/>
+        <c:axId val="2118791784"/>
+        <c:axId val="2140495176"/>
+      </c:lineChart>
+      <c:catAx>
+        <c:axId val="2118791784"/>
+        <c:scaling>
+          <c:orientation val="minMax"/>
+        </c:scaling>
+        <c:delete val="0"/>
+        <c:axPos val="b"/>
+        <c:majorTickMark val="out"/>
+        <c:minorTickMark val="none"/>
+        <c:tickLblPos val="nextTo"/>
+        <c:crossAx val="2140495176"/>
+        <c:crosses val="autoZero"/>
+        <c:auto val="1"/>
+        <c:lblAlgn val="ctr"/>
+        <c:lblOffset val="100"/>
+        <c:noMultiLvlLbl val="0"/>
+      </c:catAx>
+      <c:valAx>
+        <c:axId val="2140495176"/>
+        <c:scaling/>
+        <c:delete val="0"/>
+        <c:axPos val="l"/>
+        <c:majorGridlines/>
+        <c:majorTickMark val="out"/>
+        <c:minorTickMark val="none"/>
+        <c:tickLblPos val="nextTo"/>
+        <c:crossAx val="2118791784"/>
+        <c:crosses val="autoZero"/>
+      </c:valAx>
+    </c:plotArea>
+    <c:legend>
+      <c:legendPos val="r"/>
+      <c:layout/>
+      <c:overlay val="0"/>
+    </c:legend>
+    <c:plotVisOnly val="1"/>
+    <c:dispBlanksAs val="gap"/>
+    <c:showDLblsOverMax val="0"/>
+  </c:chart>
+  <c:txPr>
+    <a:bodyPr/>
+    <a:lstStyle/>
+    <a:p>
+      <a:pPr>
+        <a:defRPr sz="1800"/>
+      </a:pPr>
+      <a:endParaRPr lang="en-US"/>
+    </a:p>
+  </c:txPr>
+  <c:externalData r:id="rId1">
+    <c:autoUpdate val="0"/>
+  </c:externalData>
+</c:chartSpace>
 </file>
 
 <file path=ppt/slideLayouts/slideLayout1.xml><?xml version="1.0" encoding="utf-8"?>
@@ -3103,8 +3233,8 @@
         </p:nvSpPr>
         <p:spPr>
           <a:xfrm>
-            <a:off x="57600" y="43200"/>
-            <a:ext cx="576000" cy="324000"/>
+            <a:off x="731520" y="548640"/>
+            <a:ext cx="7315200" cy="4114800"/>
           </a:xfrm>
           <a:prstGeom prst="rect">
             <a:avLst/>
@@ -3154,8 +3284,8 @@
         </p:nvSpPr>
         <p:spPr>
           <a:xfrm>
-            <a:off x="57600" y="43200"/>
-            <a:ext cx="576000" cy="324000"/>
+            <a:off x="731520" y="548640"/>
+            <a:ext cx="7315200" cy="4114800"/>
           </a:xfrm>
           <a:prstGeom prst="rect">
             <a:avLst/>
@@ -3179,6 +3309,30 @@
           </a:p>
         </p:txBody>
       </p:sp>
+      <p:pic>
+        <p:nvPicPr>
+          <p:cNvPr id="3" name="Picture 2" descr="circuit_diagram.png"/>
+          <p:cNvPicPr>
+            <a:picLocks noChangeAspect="1"/>
+          </p:cNvPicPr>
+          <p:nvPr/>
+        </p:nvPicPr>
+        <p:blipFill>
+          <a:blip r:embed="rId2"/>
+          <a:stretch>
+            <a:fillRect/>
+          </a:stretch>
+        </p:blipFill>
+        <p:spPr>
+          <a:xfrm>
+            <a:off x="731520" y="3108960"/>
+            <a:ext cx="4572000" cy="2743200"/>
+          </a:xfrm>
+          <a:prstGeom prst="rect">
+            <a:avLst/>
+          </a:prstGeom>
+        </p:spPr>
+      </p:pic>
     </p:spTree>
   </p:cSld>
   <p:clrMapOvr>
@@ -3205,8 +3359,8 @@
         </p:nvSpPr>
         <p:spPr>
           <a:xfrm>
-            <a:off x="57600" y="43200"/>
-            <a:ext cx="576000" cy="324000"/>
+            <a:off x="731520" y="548640"/>
+            <a:ext cx="7315200" cy="4114800"/>
           </a:xfrm>
           <a:prstGeom prst="rect">
             <a:avLst/>
@@ -3256,8 +3410,8 @@
         </p:nvSpPr>
         <p:spPr>
           <a:xfrm>
-            <a:off x="57600" y="43200"/>
-            <a:ext cx="576000" cy="324000"/>
+            <a:off x="731520" y="548640"/>
+            <a:ext cx="7315200" cy="4114800"/>
           </a:xfrm>
           <a:prstGeom prst="rect">
             <a:avLst/>
@@ -3307,8 +3461,8 @@
         </p:nvSpPr>
         <p:spPr>
           <a:xfrm>
-            <a:off x="57600" y="43200"/>
-            <a:ext cx="576000" cy="324000"/>
+            <a:off x="731520" y="548640"/>
+            <a:ext cx="7315200" cy="4114800"/>
           </a:xfrm>
           <a:prstGeom prst="rect">
             <a:avLst/>
@@ -3358,8 +3512,8 @@
         </p:nvSpPr>
         <p:spPr>
           <a:xfrm>
-            <a:off x="57600" y="43200"/>
-            <a:ext cx="576000" cy="324000"/>
+            <a:off x="731520" y="548640"/>
+            <a:ext cx="7315200" cy="4114800"/>
           </a:xfrm>
           <a:prstGeom prst="rect">
             <a:avLst/>
@@ -3383,6 +3537,162 @@
           </a:p>
         </p:txBody>
       </p:sp>
+      <p:graphicFrame>
+        <p:nvGraphicFramePr>
+          <p:cNvPr id="3" name="Table 2"/>
+          <p:cNvGraphicFramePr>
+            <a:graphicFrameLocks noGrp="1"/>
+          </p:cNvGraphicFramePr>
+          <p:nvPr/>
+        </p:nvGraphicFramePr>
+        <p:xfrm>
+          <a:off x="57600" y="187200"/>
+          <a:ext cx="576000" cy="28800"/>
+        </p:xfrm>
+        <a:graphic>
+          <a:graphicData uri="http://schemas.openxmlformats.org/drawingml/2006/table">
+            <a:tbl>
+              <a:tblPr firstRow="1" bandRow="1">
+                <a:tableStyleId>{5C22544A-7EE6-4342-B048-85BDC9FD1C3A}</a:tableStyleId>
+              </a:tblPr>
+              <a:tblGrid>
+                <a:gridCol w="288000"/>
+                <a:gridCol w="288000"/>
+              </a:tblGrid>
+              <a:tr h="5760">
+                <a:tc>
+                  <a:txBody>
+                    <a:bodyPr/>
+                    <a:lstStyle/>
+                    <a:p>
+                      <a:r>
+                        <a:t>voltage_V</a:t>
+                      </a:r>
+                    </a:p>
+                  </a:txBody>
+                  <a:tcPr/>
+                </a:tc>
+                <a:tc>
+                  <a:txBody>
+                    <a:bodyPr/>
+                    <a:lstStyle/>
+                    <a:p>
+                      <a:r>
+                        <a:t>current_mA</a:t>
+                      </a:r>
+                    </a:p>
+                  </a:txBody>
+                  <a:tcPr/>
+                </a:tc>
+              </a:tr>
+              <a:tr h="5760">
+                <a:tc>
+                  <a:txBody>
+                    <a:bodyPr/>
+                    <a:lstStyle/>
+                    <a:p>
+                      <a:r>
+                        <a:t>3.0</a:t>
+                      </a:r>
+                    </a:p>
+                  </a:txBody>
+                  <a:tcPr/>
+                </a:tc>
+                <a:tc>
+                  <a:txBody>
+                    <a:bodyPr/>
+                    <a:lstStyle/>
+                    <a:p>
+                      <a:r>
+                        <a:t>12.0</a:t>
+                      </a:r>
+                    </a:p>
+                  </a:txBody>
+                  <a:tcPr/>
+                </a:tc>
+              </a:tr>
+              <a:tr h="5760">
+                <a:tc>
+                  <a:txBody>
+                    <a:bodyPr/>
+                    <a:lstStyle/>
+                    <a:p>
+                      <a:r>
+                        <a:t>6.0</a:t>
+                      </a:r>
+                    </a:p>
+                  </a:txBody>
+                  <a:tcPr/>
+                </a:tc>
+                <a:tc>
+                  <a:txBody>
+                    <a:bodyPr/>
+                    <a:lstStyle/>
+                    <a:p>
+                      <a:r>
+                        <a:t>24.0</a:t>
+                      </a:r>
+                    </a:p>
+                  </a:txBody>
+                  <a:tcPr/>
+                </a:tc>
+              </a:tr>
+              <a:tr h="5760">
+                <a:tc>
+                  <a:txBody>
+                    <a:bodyPr/>
+                    <a:lstStyle/>
+                    <a:p>
+                      <a:r>
+                        <a:t>9.0</a:t>
+                      </a:r>
+                    </a:p>
+                  </a:txBody>
+                  <a:tcPr/>
+                </a:tc>
+                <a:tc>
+                  <a:txBody>
+                    <a:bodyPr/>
+                    <a:lstStyle/>
+                    <a:p>
+                      <a:r>
+                        <a:t>36.0</a:t>
+                      </a:r>
+                    </a:p>
+                  </a:txBody>
+                  <a:tcPr/>
+                </a:tc>
+              </a:tr>
+              <a:tr h="5760">
+                <a:tc>
+                  <a:txBody>
+                    <a:bodyPr/>
+                    <a:lstStyle/>
+                    <a:p>
+                      <a:r>
+                        <a:t>12.0</a:t>
+                      </a:r>
+                    </a:p>
+                  </a:txBody>
+                  <a:tcPr/>
+                </a:tc>
+                <a:tc>
+                  <a:txBody>
+                    <a:bodyPr/>
+                    <a:lstStyle/>
+                    <a:p>
+                      <a:r>
+                        <a:t>48.0</a:t>
+                      </a:r>
+                    </a:p>
+                  </a:txBody>
+                  <a:tcPr/>
+                </a:tc>
+              </a:tr>
+            </a:tbl>
+          </a:graphicData>
+        </a:graphic>
+      </p:graphicFrame>
     </p:spTree>
   </p:cSld>
   <p:clrMapOvr>
@@ -3409,8 +3719,8 @@
         </p:nvSpPr>
         <p:spPr>
           <a:xfrm>
-            <a:off x="57600" y="43200"/>
-            <a:ext cx="576000" cy="324000"/>
+            <a:off x="731520" y="548640"/>
+            <a:ext cx="7315200" cy="4114800"/>
           </a:xfrm>
           <a:prstGeom prst="rect">
             <a:avLst/>
@@ -3460,8 +3770,8 @@
         </p:nvSpPr>
         <p:spPr>
           <a:xfrm>
-            <a:off x="57600" y="43200"/>
-            <a:ext cx="576000" cy="324000"/>
+            <a:off x="731520" y="548640"/>
+            <a:ext cx="7315200" cy="4114800"/>
           </a:xfrm>
           <a:prstGeom prst="rect">
             <a:avLst/>
@@ -3485,6 +3795,75 @@
           </a:p>
         </p:txBody>
       </p:sp>
+    </p:spTree>
+  </p:cSld>
+  <p:clrMapOvr>
+    <a:masterClrMapping/>
+  </p:clrMapOvr>
+</p:sld>
+</file>
+
+<file path=ppt/slides/slide9.xml><?xml version="1.0" encoding="utf-8"?>
+<p:sld xmlns:a="http://schemas.openxmlformats.org/drawingml/2006/main" xmlns:p="http://schemas.openxmlformats.org/presentationml/2006/main" xmlns:r="http://schemas.openxmlformats.org/officeDocument/2006/relationships">
+  <p:cSld>
+    <p:spTree>
+      <p:nvGrpSpPr>
+        <p:cNvPr id="1" name=""/>
+        <p:cNvGrpSpPr/>
+        <p:nvPr/>
+      </p:nvGrpSpPr>
+      <p:grpSpPr/>
+      <p:sp>
+        <p:nvSpPr>
+          <p:cNvPr id="2" name="TextBox 1"/>
+          <p:cNvSpPr txBox="1"/>
+          <p:nvPr/>
+        </p:nvSpPr>
+        <p:spPr>
+          <a:xfrm>
+            <a:off x="731520" y="274320"/>
+            <a:ext cx="7315200" cy="914400"/>
+          </a:xfrm>
+          <a:prstGeom prst="rect">
+            <a:avLst/>
+          </a:prstGeom>
+          <a:noFill/>
+        </p:spPr>
+        <p:txBody>
+          <a:bodyPr wrap="none">
+            <a:spAutoFit/>
+          </a:bodyPr>
+          <a:lstStyle/>
+          <a:p>
+            <a:r>
+              <a:t>V-I is a straight line through the origin</a:t>
+            </a:r>
+          </a:p>
+          <a:p>
+            <a:r>
+              <a:t>Slope is 1/R. MARKER-PPT-CHART.</a:t>
+            </a:r>
+          </a:p>
+        </p:txBody>
+      </p:sp>
+      <p:graphicFrame>
+        <p:nvGraphicFramePr>
+          <p:cNvPr id="3" name="Chart 2"/>
+          <p:cNvGraphicFramePr>
+            <a:graphicFrameLocks noGrp="1"/>
+          </p:cNvGraphicFramePr>
+          <p:nvPr/>
+        </p:nvGraphicFramePr>
+        <p:xfrm>
+          <a:off x="731520" y="1463040"/>
+          <a:ext cx="7315200" cy="4114800"/>
+        </p:xfrm>
+        <a:graphic>
+          <a:graphicData uri="http://schemas.openxmlformats.org/drawingml/2006/chart">
+            <c:chart xmlns:c="http://schemas.openxmlformats.org/drawingml/2006/chart" r:id="rId2"/>
+          </a:graphicData>
+        </a:graphic>
+      </p:graphicFrame>
     </p:spTree>
   </p:cSld>
   <p:clrMapOvr>

</xml_diff>